<commit_message>
Correct attributions, dates and diagram text in mind slideshows
Smart (not Putnam) credited for identity theory quotations; Putnam paper
date corrected; SmartArt text proofread; knowledge argument responses
renumbered and titled 'Four responses'.

Co-Authored-By: Claude Opus 5.5 <noreply@anthropic.com>
Claude-Session: https://claude.ai/code/session_01G8vir49r24TcDKygSJVSXY
</commit_message>
<xml_diff>
--- a/downloads/Mind_Brain_Identity_Theory_Slides.pptx
+++ b/downloads/Mind_Brain_Identity_Theory_Slides.pptx
@@ -10290,7 +10290,7 @@
                 </a:solidFill>
                 <a:latin typeface="Avenir Book" panose="02000503020000020003" pitchFamily="2" charset="0"/>
               </a:rPr>
-              <a:t>‘Insofar as ‘after-image’ or ‘ache’ is a report of a process, it is a report of a process that happens to be a brain process…All it claims is that in so far as a sensation statement is a reporting of something, that something is in fact a brain process. Sensations are nothing over and above brain processes.’ (In the same way that nations are nothing ‘over and above’ their citizens). Hilary Putnam</a:t>
+              <a:t>‘Insofar as ‘after-image’ or ‘ache’ is a report of a process, it is a report of a process that happens to be a brain process…All it claims is that in so far as a sensation statement is a reporting of something, that something is in fact a brain process. Sensations are nothing over and above brain processes.’ (In the same way that nations are nothing ‘over and above’ their citizens). J.J.C. Smart, ‘Sensations and Brain Processes’ (1959)</a:t>
             </a:r>
           </a:p>
         </p:txBody>
@@ -10658,7 +10658,7 @@
                 </a:solidFill>
                 <a:latin typeface="Avenir Book" panose="02000503020000020003" pitchFamily="2" charset="0"/>
               </a:rPr>
-              <a:t>“When I say that a sensation is a brain process or that lightning is an electrical discharge, I am using ‘is’ in the sense of strict identity” Hilary Putnam</a:t>
+              <a:t>“When I say that a sensation is a brain process or that lightning is an electrical discharge, I am using ‘is’ in the sense of strict identity” J.J.C. Smart, ‘Sensations and Brain Processes’ (1959)</a:t>
             </a:r>
           </a:p>
         </p:txBody>

</xml_diff>